<commit_message>
Actualiza presentación de Fase 1 a la versión más reciente
</commit_message>
<xml_diff>
--- a/Fase1/Evidencias_grupales/02_Presentacion_Proyecto_Fase1_Aprueba_Administracion.pptx
+++ b/Fase1/Evidencias_grupales/02_Presentacion_Proyecto_Fase1_Aprueba_Administracion.pptx
@@ -117,6 +117,11 @@
       </a:defRPr>
     </a:lvl9pPr>
   </p:defaultTextStyle>
+  <p:extLst>
+    <p:ext uri="{EFAFB233-063F-42B5-8137-9DF3F51BA10A}">
+      <p15:sldGuideLst xmlns:p15="http://schemas.microsoft.com/office/powerpoint/2012/main"/>
+    </p:ext>
+  </p:extLst>
 </p:presentation>
 </file>
 
@@ -3000,12 +3005,12 @@
               </a:defRPr>
             </a:pPr>
             <a:r>
-              <a:rPr sz="1275" b="0">
+              <a:rPr sz="1275" b="0" dirty="0">
                 <a:solidFill>
                   <a:srgbClr val="1E293B"/>
                 </a:solidFill>
               </a:rPr>
-              <a:t>Gantt, RACI, RAID y decisiones</a:t>
+              <a:t>Gantt, RACI</a:t>
             </a:r>
           </a:p>
         </p:txBody>
@@ -3587,57 +3592,6 @@
             <a:prstDash val="solid"/>
           </a:ln>
         </p:spPr>
-      </p:sp>
-      <p:sp>
-        <p:nvSpPr>
-          <p:cNvPr id="31" name="Rectángulo 30">
-            <a:extLst>
-              <a:ext uri="{FF2B5EF4-FFF2-40B4-BE49-F238E27FC236}">
-                <a16:creationId xmlns:a16="http://schemas.microsoft.com/office/drawing/2014/main" id="{E228BFC7-02EA-42CE-8091-984EC808D2E1}"/>
-              </a:ext>
-            </a:extLst>
-          </p:cNvPr>
-          <p:cNvSpPr>
-            <a:spLocks noGrp="1"/>
-          </p:cNvSpPr>
-          <p:nvPr/>
-        </p:nvSpPr>
-        <p:spPr>
-          <a:xfrm>
-            <a:off x="628650" y="6515100"/>
-            <a:ext cx="8953500" cy="209550"/>
-          </a:xfrm>
-          <a:prstGeom prst="rect">
-            <a:avLst/>
-          </a:prstGeom>
-          <a:noFill/>
-          <a:ln w="0">
-            <a:noFill/>
-            <a:prstDash val="solid"/>
-          </a:ln>
-        </p:spPr>
-        <p:txBody>
-          <a:bodyPr anchor="ctr"/>
-          <a:lstStyle/>
-          <a:p>
-            <a:pPr algn="l">
-              <a:buNone/>
-              <a:defRPr sz="825" b="0">
-                <a:solidFill>
-                  <a:srgbClr val="64748B"/>
-                </a:solidFill>
-              </a:defRPr>
-            </a:pPr>
-            <a:r>
-              <a:rPr sz="825" b="0">
-                <a:solidFill>
-                  <a:srgbClr val="64748B"/>
-                </a:solidFill>
-              </a:rPr>
-              <a:t>Condición: nombres, criterios y justificaciones deben validarse con el docente.</a:t>
-            </a:r>
-          </a:p>
-        </p:txBody>
       </p:sp>
     </p:spTree>
     <p:extLst>
@@ -3947,7 +3901,7 @@
         <p:spPr>
           <a:xfrm>
             <a:off x="628650" y="4495800"/>
-            <a:ext cx="7429500" cy="876300"/>
+            <a:ext cx="7429500" cy="58093"/>
           </a:xfrm>
           <a:prstGeom prst="roundRect">
             <a:avLst>
@@ -3965,57 +3919,6 @@
           </a:ln>
         </p:spPr>
       </p:sp>
-      <p:sp>
-        <p:nvSpPr>
-          <p:cNvPr id="7" name="Rectángulo 6">
-            <a:extLst>
-              <a:ext uri="{FF2B5EF4-FFF2-40B4-BE49-F238E27FC236}">
-                <a16:creationId xmlns:a16="http://schemas.microsoft.com/office/drawing/2014/main" id="{4C46566A-F150-4CFA-ADAE-FAB67252A054}"/>
-              </a:ext>
-            </a:extLst>
-          </p:cNvPr>
-          <p:cNvSpPr>
-            <a:spLocks noGrp="1"/>
-          </p:cNvSpPr>
-          <p:nvPr/>
-        </p:nvSpPr>
-        <p:spPr>
-          <a:xfrm>
-            <a:off x="895350" y="4667250"/>
-            <a:ext cx="6896100" cy="523875"/>
-          </a:xfrm>
-          <a:prstGeom prst="rect">
-            <a:avLst/>
-          </a:prstGeom>
-          <a:noFill/>
-          <a:ln w="0">
-            <a:noFill/>
-            <a:prstDash val="solid"/>
-          </a:ln>
-        </p:spPr>
-        <p:txBody>
-          <a:bodyPr anchor="ctr"/>
-          <a:lstStyle/>
-          <a:p>
-            <a:pPr algn="ctr">
-              <a:buNone/>
-              <a:defRPr sz="1650" b="1">
-                <a:solidFill>
-                  <a:srgbClr val="1A365D"/>
-                </a:solidFill>
-              </a:defRPr>
-            </a:pPr>
-            <a:r>
-              <a:rPr sz="1650" b="1">
-                <a:solidFill>
-                  <a:srgbClr val="1A365D"/>
-                </a:solidFill>
-              </a:rPr>
-              <a:t>SOLICITUD: aprobar la definición y validar los criterios de evidencia para iniciar la ejecución.</a:t>
-            </a:r>
-          </a:p>
-        </p:txBody>
-      </p:sp>
       <p:pic>
         <p:nvPicPr>
           <p:cNvPr id="20" name="Imagen 19"/>
@@ -4038,144 +3941,6 @@
           </a:prstGeom>
         </p:spPr>
       </p:pic>
-      <p:sp>
-        <p:nvSpPr>
-          <p:cNvPr id="9" name="Rectángulo 8">
-            <a:extLst>
-              <a:ext uri="{FF2B5EF4-FFF2-40B4-BE49-F238E27FC236}">
-                <a16:creationId xmlns:a16="http://schemas.microsoft.com/office/drawing/2014/main" id="{D3A87421-791B-42C6-AC5C-5378FDC7ECF2}"/>
-              </a:ext>
-            </a:extLst>
-          </p:cNvPr>
-          <p:cNvSpPr>
-            <a:spLocks noGrp="1"/>
-          </p:cNvSpPr>
-          <p:nvPr/>
-        </p:nvSpPr>
-        <p:spPr>
-          <a:xfrm>
-            <a:off x="8858250" y="4095750"/>
-            <a:ext cx="2095500" cy="247650"/>
-          </a:xfrm>
-          <a:prstGeom prst="rect">
-            <a:avLst/>
-          </a:prstGeom>
-          <a:noFill/>
-          <a:ln w="0">
-            <a:noFill/>
-            <a:prstDash val="solid"/>
-          </a:ln>
-        </p:spPr>
-        <p:txBody>
-          <a:bodyPr anchor="ctr"/>
-          <a:lstStyle/>
-          <a:p>
-            <a:pPr algn="ctr">
-              <a:buNone/>
-              <a:defRPr sz="975" b="1">
-                <a:solidFill>
-                  <a:srgbClr val="F5B041"/>
-                </a:solidFill>
-              </a:defRPr>
-            </a:pPr>
-            <a:r>
-              <a:rPr sz="975" b="1">
-                <a:solidFill>
-                  <a:srgbClr val="F5B041"/>
-                </a:solidFill>
-              </a:rPr>
-              <a:t>Siguiente paso</a:t>
-            </a:r>
-          </a:p>
-        </p:txBody>
-      </p:sp>
-      <p:sp>
-        <p:nvSpPr>
-          <p:cNvPr id="10" name="Rectángulo 9">
-            <a:extLst>
-              <a:ext uri="{FF2B5EF4-FFF2-40B4-BE49-F238E27FC236}">
-                <a16:creationId xmlns:a16="http://schemas.microsoft.com/office/drawing/2014/main" id="{65558388-E3FD-4EEE-8E2D-90C833ECB727}"/>
-              </a:ext>
-            </a:extLst>
-          </p:cNvPr>
-          <p:cNvSpPr>
-            <a:spLocks noGrp="1"/>
-          </p:cNvSpPr>
-          <p:nvPr/>
-        </p:nvSpPr>
-        <p:spPr>
-          <a:xfrm>
-            <a:off x="8572500" y="4457700"/>
-            <a:ext cx="2667000" cy="1028700"/>
-          </a:xfrm>
-          <a:prstGeom prst="rect">
-            <a:avLst/>
-          </a:prstGeom>
-          <a:noFill/>
-          <a:ln w="0">
-            <a:noFill/>
-            <a:prstDash val="solid"/>
-          </a:ln>
-        </p:spPr>
-        <p:txBody>
-          <a:bodyPr anchor="ctr"/>
-          <a:lstStyle/>
-          <a:p>
-            <a:pPr algn="ctr">
-              <a:buNone/>
-              <a:defRPr sz="1425" b="1">
-                <a:solidFill>
-                  <a:srgbClr val="FFFFFF"/>
-                </a:solidFill>
-              </a:defRPr>
-            </a:pPr>
-            <a:r>
-              <a:rPr sz="1425" b="1">
-                <a:solidFill>
-                  <a:srgbClr val="FFFFFF"/>
-                </a:solidFill>
-              </a:rPr>
-              <a:t>Docente valida evidencias</a:t>
-            </a:r>
-          </a:p>
-          <a:p>
-            <a:pPr algn="ctr">
-              <a:buNone/>
-              <a:defRPr sz="1425" b="1">
-                <a:solidFill>
-                  <a:srgbClr val="FFFFFF"/>
-                </a:solidFill>
-              </a:defRPr>
-            </a:pPr>
-            <a:r>
-              <a:rPr sz="1425" b="1">
-                <a:solidFill>
-                  <a:srgbClr val="FFFFFF"/>
-                </a:solidFill>
-              </a:rPr>
-              <a:t>Equipo ajusta la línea base</a:t>
-            </a:r>
-          </a:p>
-          <a:p>
-            <a:pPr algn="ctr">
-              <a:buNone/>
-              <a:defRPr sz="1425" b="1">
-                <a:solidFill>
-                  <a:srgbClr val="FFFFFF"/>
-                </a:solidFill>
-              </a:defRPr>
-            </a:pPr>
-            <a:r>
-              <a:rPr sz="1425" b="1">
-                <a:solidFill>
-                  <a:srgbClr val="FFFFFF"/>
-                </a:solidFill>
-              </a:rPr>
-              <a:t>Se inicia Sprint 1</a:t>
-            </a:r>
-          </a:p>
-        </p:txBody>
-      </p:sp>
     </p:spTree>
     <p:extLst>
       <p:ext uri="{BB962C8B-B14F-4D97-AF65-F5344CB8AC3E}">

</xml_diff>